<commit_message>
Rewrite the Level 4 listening lines the checker rejected
</commit_message>
<xml_diff>
--- a/level4/slides/Level4_Lesson11_Slides.pptx
+++ b/level4/slides/Level4_Lesson11_Slides.pptx
@@ -1216,12 +1216,12 @@
           </a:p>
           <a:p>
             <a:r>
-              <a:t>Ms. Adams: Sure, Luis. When do you want to take it?</a:t>
-            </a:r>
-          </a:p>
-          <a:p>
-            <a:r>
-              <a:t>Luis: Next month, from Thursday, June fifth, to Saturday, June seventh. That's three days.</a:t>
+              <a:t>Ms. Adams: Sure. When do you want to take the time off?</a:t>
+            </a:r>
+          </a:p>
+          <a:p>
+            <a:r>
+              <a:t>Luis: Next month, from Thursday the fifth of June to Saturday the seventh of June. That's three days.</a:t>
             </a:r>
           </a:p>
           <a:p>
@@ -1231,7 +1231,7 @@
           </a:p>
           <a:p>
             <a:r>
-              <a:t>Luis: To visit my mother in San Antonio. It's her seventieth birthday.</a:t>
+              <a:t>Luis: To visit my mother in San Antonio. She is turning seventy.</a:t>
             </a:r>
           </a:p>
           <a:p>
@@ -1251,7 +1251,7 @@
           </a:p>
           <a:p>
             <a:r>
-              <a:t>Luis: Ana has agreed to cover Thursday and Friday. I'm still looking for someone for Saturday.</a:t>
+              <a:t>Luis: Anna has agreed to cover Thursday and Friday. I'm still looking for someone for Saturday.</a:t>
             </a:r>
           </a:p>
           <a:p>
@@ -1266,7 +1266,7 @@
           </a:p>
           <a:p>
             <a:r>
-              <a:t>Luis: Hi, Rosa, it's Luis. I'm calling to tell you about my trip. I'm going to take the bus on Thursday, June fifth. It's bus number forty-two, and it gets to San Antonio at six thirty p.m. Can you pick me up at the bus station? Also, don't forget to bring Mom's birthday card. I want everyone to sign it. Call me back at five five five, two one four, eight eight three zero. Bye!</a:t>
+              <a:t>Luis: Hi, Rosa, it's Luis. I'm calling to tell you about my trip. I'm going to take the bus on Thursday, June fifth. It's bus number forty-two, and it gets to San Antonio at six thirty in the evening. Can you pick me up at the bus station? Also, don't forget to bring Mom's birthday card. I want everyone to sign it. Call me back at five five five, two one four, eight eight three zero. Bye!</a:t>
             </a:r>
           </a:p>
           <a:p>
@@ -13527,7 +13527,7 @@
             </a:pPr>
             <a:r>
               <a:rPr lang="en-US" sz="1600" dirty="0"/>
-              <a:t>3. Ana will cover</a:t>
+              <a:t>3. Anna will cover</a:t>
             </a:r>
             <a:endParaRPr lang="en-US" sz="1600" dirty="0"/>
           </a:p>

</xml_diff>